<commit_message>
test(research): add pre-covid event placebo guardrail
</commit_message>
<xml_diff>
--- a/outputs/final_project/NHTS_Travel_Behavior_Template_Presentation.pptx
+++ b/outputs/final_project/NHTS_Travel_Behavior_Template_Presentation.pptx
@@ -14708,7 +14708,7 @@
                 </a:solidFill>
                 <a:latin typeface="Microsoft YaHei"/>
               </a:rPr>
-              <a:t>方式结构是否已经解决？</a:t>
+              <a:t>是否只是通用下调？</a:t>
             </a:r>
           </a:p>
         </p:txBody>
@@ -14795,7 +14795,7 @@
                 </a:solidFill>
                 <a:latin typeface="Microsoft YaHei"/>
               </a:rPr>
-              <a:t>还没有；主要是 transit 维度更清楚</a:t>
+              <a:t>pre-COVID placebo 中 full suppression 会过度修正</a:t>
             </a:r>
           </a:p>
         </p:txBody>

</xml_diff>

<commit_message>
docs(research): add causal guardrails and method comparison brief
</commit_message>
<xml_diff>
--- a/outputs/final_project/NHTS_Travel_Behavior_Template_Presentation.pptx
+++ b/outputs/final_project/NHTS_Travel_Behavior_Template_Presentation.pptx
@@ -20127,7 +20127,7 @@
           <a:lstStyle/>
           <a:p>
             <a:pPr algn="l">
-              <a:defRPr sz="1200" b="1">
+              <a:defRPr sz="1050" b="1">
                 <a:solidFill>
                   <a:srgbClr val="0F172A"/>
                 </a:solidFill>
@@ -20135,13 +20135,13 @@
               </a:defRPr>
             </a:pPr>
             <a:r>
-              <a:rPr sz="1200" b="1">
+              <a:rPr sz="1050" b="1">
                 <a:solidFill>
                   <a:srgbClr val="0F172A"/>
                 </a:solidFill>
                 <a:latin typeface="Microsoft YaHei"/>
               </a:rPr>
-              <a:t>LLM 输出的是 s_event，不是 y；最终预测 = 历史 household baseline × 事件折减系数。</a:t>
+              <a:t>LLM-only has direction but weaker calibration: wMAE 2.72 -&gt; 2.50; wBias -0.37 -&gt; -0.02.</a:t>
             </a:r>
           </a:p>
         </p:txBody>

</xml_diff>

<commit_message>
docs(research): add 2026 literature grounding
Add a 2025-2026 literature positioning note for event-driven LLM mobility, causal event features, zero-shot mobility agents, and mobility foundation models. Update README, final report, paper logic chain, and the template presentation related-work slide.
</commit_message>
<xml_diff>
--- a/outputs/final_project/NHTS_Travel_Behavior_Template_Presentation.pptx
+++ b/outputs/final_project/NHTS_Travel_Behavior_Template_Presentation.pptx
@@ -35418,7 +35418,7 @@
                 </a:solidFill>
                 <a:latin typeface="Microsoft YaHei"/>
               </a:rPr>
-              <a:t>从交通预测到 LLM 事件泛化</a:t>
+              <a:t>2025-2026: LLM mobility, causal events, and foundation models</a:t>
             </a:r>
           </a:p>
         </p:txBody>
@@ -35697,7 +35697,7 @@
                 </a:solidFill>
                 <a:latin typeface="Microsoft YaHei"/>
               </a:rPr>
-              <a:t>研究方向</a:t>
+              <a:t>最新方向</a:t>
             </a:r>
           </a:p>
         </p:txBody>
@@ -35782,7 +35782,7 @@
                 </a:solidFill>
                 <a:latin typeface="Microsoft YaHei"/>
               </a:rPr>
-              <a:t>已有做法</a:t>
+              <a:t>2025-2026 代表线索</a:t>
             </a:r>
           </a:p>
         </p:txBody>
@@ -35867,7 +35867,7 @@
                 </a:solidFill>
                 <a:latin typeface="Microsoft YaHei"/>
               </a:rPr>
-              <a:t>本项目的切入点</a:t>
+              <a:t>本项目的位置</a:t>
             </a:r>
           </a:p>
         </p:txBody>
@@ -35954,7 +35954,7 @@
                 </a:solidFill>
                 <a:latin typeface="Microsoft YaHei"/>
               </a:rPr>
-              <a:t>Travel demand modeling</a:t>
+              <a:t>Event-driven mobility</a:t>
             </a:r>
           </a:p>
         </p:txBody>
@@ -36041,7 +36041,7 @@
                 </a:solidFill>
                 <a:latin typeface="Microsoft YaHei"/>
               </a:rPr>
-              <a:t>用 household covariates 预测出行强度/方式</a:t>
+              <a:t>ELLMob ICLR'26; CausalMob KDD'25</a:t>
             </a:r>
           </a:p>
         </p:txBody>
@@ -36128,7 +36128,7 @@
                 </a:solidFill>
                 <a:latin typeface="Microsoft YaHei"/>
               </a:rPr>
-              <a:t>2022 是疫情后 shift，不是普通外推</a:t>
+              <a:t>把 COVID shock 转成 label-free event priors</a:t>
             </a:r>
           </a:p>
         </p:txBody>
@@ -36215,7 +36215,7 @@
                 </a:solidFill>
                 <a:latin typeface="Microsoft YaHei"/>
               </a:rPr>
-              <a:t>ML for NHTS</a:t>
+              <a:t>Zero-shot LLM mobility</a:t>
             </a:r>
           </a:p>
         </p:txBody>
@@ -36302,7 +36302,7 @@
                 </a:solidFill>
                 <a:latin typeface="Microsoft YaHei"/>
               </a:rPr>
-              <a:t>XGBoost 等模型捕捉非线性家庭差异</a:t>
+              <a:t>AgentMove NAACL'25; ELP-Mob GIS'25</a:t>
             </a:r>
           </a:p>
         </p:txBody>
@@ -36389,7 +36389,7 @@
                 </a:solidFill>
                 <a:latin typeface="Microsoft YaHei"/>
               </a:rPr>
-              <a:t>传统监督模型缺少事件机制变量</a:t>
+              <a:t>直接 LLM 可做 baseline，但数值校准弱</a:t>
             </a:r>
           </a:p>
         </p:txBody>
@@ -36476,7 +36476,7 @@
                 </a:solidFill>
                 <a:latin typeface="Microsoft YaHei"/>
               </a:rPr>
-              <a:t>LLM mobility forecasting</a:t>
+              <a:t>Mobility foundation models</a:t>
             </a:r>
           </a:p>
         </p:txBody>
@@ -36563,7 +36563,7 @@
                 </a:solidFill>
                 <a:latin typeface="Microsoft YaHei"/>
               </a:rPr>
-              <a:t>利用文本事件、语义和少样本泛化</a:t>
+              <a:t>UniMob KDD'25; STFM survey'25</a:t>
             </a:r>
           </a:p>
         </p:txBody>
@@ -36650,7 +36650,7 @@
                 </a:solidFill>
                 <a:latin typeface="Microsoft YaHei"/>
               </a:rPr>
-              <a:t>LLM 不直接预测 y，只生成 event priors</a:t>
+              <a:t>不训练大 FM；用轻量 adapter 处理 survey shift</a:t>
             </a:r>
           </a:p>
         </p:txBody>
@@ -36737,7 +36737,7 @@
                 </a:solidFill>
                 <a:latin typeface="Microsoft YaHei"/>
               </a:rPr>
-              <a:t>Sustainable mobility</a:t>
+              <a:t>Planning evaluation</a:t>
             </a:r>
           </a:p>
         </p:txBody>
@@ -36824,7 +36824,7 @@
                 </a:solidFill>
                 <a:latin typeface="Microsoft YaHei"/>
               </a:rPr>
-              <a:t>关注 transit、active mobility 与不平等</a:t>
+              <a:t>causal guardrails + multi-objective metrics</a:t>
             </a:r>
           </a:p>
         </p:txBody>
@@ -36911,7 +36911,7 @@
                 </a:solidFill>
                 <a:latin typeface="Microsoft YaHei"/>
               </a:rPr>
-              <a:t>输出扩展到 mode / purpose / derived trips</a:t>
+              <a:t>同时报告 accuracy、bias、equity、mode/purpose</a:t>
             </a:r>
           </a:p>
         </p:txBody>
@@ -37040,7 +37040,7 @@
                 </a:solidFill>
                 <a:latin typeface="Microsoft YaHei"/>
               </a:rPr>
-              <a:t>缺的不是更复杂的黑箱，而是一个能把“日常出行规律”和“疫情事件机制”组合起来、且不依赖 2022 标签校准的可解释框架。</a:t>
+              <a:t>缺口：已有工作多关注 trajectory / flow / sensor forecasting；NHTS household survey 的 post-pandemic label-free event adaptation 仍需要一个可解释、可审计框架。</a:t>
             </a:r>
           </a:p>
         </p:txBody>

</xml_diff>

<commit_message>
feat(research): add external mechanism validation
</commit_message>
<xml_diff>
--- a/outputs/final_project/NHTS_Travel_Behavior_Template_Presentation.pptx
+++ b/outputs/final_project/NHTS_Travel_Behavior_Template_Presentation.pptx
@@ -37,6 +37,7 @@
     <p:sldId id="282" r:id="rId33"/>
     <p:sldId id="283" r:id="rId34"/>
     <p:sldId id="284" r:id="rId35"/>
+    <p:sldId id="285" r:id="rId36"/>
   </p:sldIdLst>
   <p:sldSz cx="12192000" cy="6858000"/>
   <p:notesSz cx="6858000" cy="9144000"/>
@@ -44508,6 +44509,1552 @@
               </a:rPr>
               <a:t>Core question: can event priors correct the post-pandemic overprediction without using 2022 target labels for calibration?</a:t>
             </a:r>
+          </a:p>
+        </p:txBody>
+      </p:sp>
+    </p:spTree>
+  </p:cSld>
+  <p:clrMapOvr>
+    <a:masterClrMapping/>
+  </p:clrMapOvr>
+</p:sld>
+</file>
+
+<file path=ppt/slides/slide30.xml><?xml version="1.0" encoding="utf-8"?>
+<p:sld xmlns:a="http://schemas.openxmlformats.org/drawingml/2006/main" xmlns:p="http://schemas.openxmlformats.org/presentationml/2006/main" xmlns:r="http://schemas.openxmlformats.org/officeDocument/2006/relationships">
+  <p:cSld>
+    <p:bg>
+      <p:bgPr>
+        <a:solidFill>
+          <a:srgbClr val="FFFFFF"/>
+        </a:solidFill>
+        <a:effectLst/>
+      </p:bgPr>
+    </p:bg>
+    <p:spTree>
+      <p:nvGrpSpPr>
+        <p:cNvPr id="1" name=""/>
+        <p:cNvGrpSpPr/>
+        <p:nvPr/>
+      </p:nvGrpSpPr>
+      <p:grpSpPr/>
+      <p:sp>
+        <p:nvSpPr>
+          <p:cNvPr id="2" name="TextBox 1"/>
+          <p:cNvSpPr txBox="1"/>
+          <p:nvPr/>
+        </p:nvSpPr>
+        <p:spPr>
+          <a:xfrm>
+            <a:off x="384048" y="109728"/>
+            <a:ext cx="4480560" cy="164592"/>
+          </a:xfrm>
+          <a:prstGeom prst="rect">
+            <a:avLst/>
+          </a:prstGeom>
+          <a:noFill/>
+        </p:spPr>
+        <p:txBody>
+          <a:bodyPr wrap="square" lIns="27432" rIns="27432" tIns="9144" bIns="9144" anchor="ctr">
+            <a:spAutoFit/>
+          </a:bodyPr>
+          <a:lstStyle/>
+          <a:p>
+            <a:pPr algn="l">
+              <a:defRPr sz="750" b="1">
+                <a:solidFill>
+                  <a:srgbClr val="64748B"/>
+                </a:solidFill>
+                <a:latin typeface="Microsoft YaHei"/>
+              </a:defRPr>
+            </a:pPr>
+            <a:r>
+              <a:rPr sz="750" b="1">
+                <a:solidFill>
+                  <a:srgbClr val="64748B"/>
+                </a:solidFill>
+                <a:latin typeface="Microsoft YaHei"/>
+              </a:rPr>
+              <a:t>Mobility Inequality and Sustainable Development</a:t>
+            </a:r>
+          </a:p>
+        </p:txBody>
+      </p:sp>
+      <p:sp>
+        <p:nvSpPr>
+          <p:cNvPr id="3" name="TextBox 2"/>
+          <p:cNvSpPr txBox="1"/>
+          <p:nvPr/>
+        </p:nvSpPr>
+        <p:spPr>
+          <a:xfrm>
+            <a:off x="384048" y="347472"/>
+            <a:ext cx="777240" cy="292608"/>
+          </a:xfrm>
+          <a:prstGeom prst="rect">
+            <a:avLst/>
+          </a:prstGeom>
+          <a:noFill/>
+        </p:spPr>
+        <p:txBody>
+          <a:bodyPr wrap="square" lIns="27432" rIns="27432" tIns="9144" bIns="9144" anchor="ctr">
+            <a:spAutoFit/>
+          </a:bodyPr>
+          <a:lstStyle/>
+          <a:p>
+            <a:pPr algn="l">
+              <a:defRPr sz="1300" b="1">
+                <a:solidFill>
+                  <a:srgbClr val="EA580C"/>
+                </a:solidFill>
+                <a:latin typeface="Microsoft YaHei"/>
+              </a:defRPr>
+            </a:pPr>
+            <a:r>
+              <a:rPr sz="1300" b="1">
+                <a:solidFill>
+                  <a:srgbClr val="EA580C"/>
+                </a:solidFill>
+                <a:latin typeface="Microsoft YaHei"/>
+              </a:rPr>
+              <a:t>BACKUP</a:t>
+            </a:r>
+          </a:p>
+        </p:txBody>
+      </p:sp>
+      <p:sp>
+        <p:nvSpPr>
+          <p:cNvPr id="4" name="TextBox 3"/>
+          <p:cNvSpPr txBox="1"/>
+          <p:nvPr/>
+        </p:nvSpPr>
+        <p:spPr>
+          <a:xfrm>
+            <a:off x="1234440" y="246888"/>
+            <a:ext cx="8412480" cy="329184"/>
+          </a:xfrm>
+          <a:prstGeom prst="rect">
+            <a:avLst/>
+          </a:prstGeom>
+          <a:noFill/>
+        </p:spPr>
+        <p:txBody>
+          <a:bodyPr wrap="square" lIns="27432" rIns="27432" tIns="9144" bIns="9144" anchor="ctr">
+            <a:spAutoFit/>
+          </a:bodyPr>
+          <a:lstStyle/>
+          <a:p>
+            <a:pPr algn="l">
+              <a:defRPr sz="1700" b="1">
+                <a:solidFill>
+                  <a:srgbClr val="0F172A"/>
+                </a:solidFill>
+                <a:latin typeface="Microsoft YaHei"/>
+              </a:defRPr>
+            </a:pPr>
+            <a:r>
+              <a:rPr sz="1700" b="1">
+                <a:solidFill>
+                  <a:srgbClr val="0F172A"/>
+                </a:solidFill>
+                <a:latin typeface="Microsoft YaHei"/>
+              </a:rPr>
+              <a:t>有没有 NHTS 之外的外部验证？</a:t>
+            </a:r>
+          </a:p>
+        </p:txBody>
+      </p:sp>
+      <p:sp>
+        <p:nvSpPr>
+          <p:cNvPr id="5" name="TextBox 4"/>
+          <p:cNvSpPr txBox="1"/>
+          <p:nvPr/>
+        </p:nvSpPr>
+        <p:spPr>
+          <a:xfrm>
+            <a:off x="1252728" y="585216"/>
+            <a:ext cx="8869680" cy="228600"/>
+          </a:xfrm>
+          <a:prstGeom prst="rect">
+            <a:avLst/>
+          </a:prstGeom>
+          <a:noFill/>
+        </p:spPr>
+        <p:txBody>
+          <a:bodyPr wrap="square" lIns="27432" rIns="27432" tIns="9144" bIns="9144" anchor="ctr">
+            <a:spAutoFit/>
+          </a:bodyPr>
+          <a:lstStyle/>
+          <a:p>
+            <a:pPr algn="l">
+              <a:defRPr sz="850" b="0">
+                <a:solidFill>
+                  <a:srgbClr val="64748B"/>
+                </a:solidFill>
+                <a:latin typeface="Microsoft YaHei"/>
+              </a:defRPr>
+            </a:pPr>
+            <a:r>
+              <a:rPr sz="850" b="0">
+                <a:solidFill>
+                  <a:srgbClr val="64748B"/>
+                </a:solidFill>
+                <a:latin typeface="Microsoft YaHei"/>
+              </a:rPr>
+              <a:t>Do we have validation beyond NHTS?</a:t>
+            </a:r>
+          </a:p>
+        </p:txBody>
+      </p:sp>
+      <p:pic>
+        <p:nvPicPr>
+          <p:cNvPr id="6" name="Picture 5" descr="image.png"/>
+          <p:cNvPicPr>
+            <a:picLocks noChangeAspect="1"/>
+          </p:cNvPicPr>
+          <p:nvPr/>
+        </p:nvPicPr>
+        <p:blipFill>
+          <a:blip r:embed="rId2"/>
+          <a:stretch>
+            <a:fillRect/>
+          </a:stretch>
+        </p:blipFill>
+        <p:spPr>
+          <a:xfrm>
+            <a:off x="11018520" y="201168"/>
+            <a:ext cx="713232" cy="502730"/>
+          </a:xfrm>
+          <a:prstGeom prst="rect">
+            <a:avLst/>
+          </a:prstGeom>
+        </p:spPr>
+      </p:pic>
+      <p:sp>
+        <p:nvSpPr>
+          <p:cNvPr id="7" name="Rectangle 6"/>
+          <p:cNvSpPr/>
+          <p:nvPr/>
+        </p:nvSpPr>
+        <p:spPr>
+          <a:xfrm>
+            <a:off x="384048" y="877824"/>
+            <a:ext cx="11201400" cy="10972"/>
+          </a:xfrm>
+          <a:prstGeom prst="rect">
+            <a:avLst/>
+          </a:prstGeom>
+          <a:solidFill>
+            <a:srgbClr val="CBD5E1"/>
+          </a:solidFill>
+          <a:ln>
+            <a:noFill/>
+          </a:ln>
+        </p:spPr>
+        <p:style>
+          <a:lnRef idx="1">
+            <a:schemeClr val="accent1"/>
+          </a:lnRef>
+          <a:fillRef idx="3">
+            <a:schemeClr val="accent1"/>
+          </a:fillRef>
+          <a:effectRef idx="2">
+            <a:schemeClr val="accent1"/>
+          </a:effectRef>
+          <a:fontRef idx="minor">
+            <a:schemeClr val="lt1"/>
+          </a:fontRef>
+        </p:style>
+        <p:txBody>
+          <a:bodyPr rtlCol="0" anchor="ctr"/>
+          <a:lstStyle/>
+          <a:p>
+            <a:pPr algn="ctr"/>
+          </a:p>
+        </p:txBody>
+      </p:sp>
+      <p:sp>
+        <p:nvSpPr>
+          <p:cNvPr id="8" name="Rectangle 7"/>
+          <p:cNvSpPr/>
+          <p:nvPr/>
+        </p:nvSpPr>
+        <p:spPr>
+          <a:xfrm>
+            <a:off x="384048" y="6428232"/>
+            <a:ext cx="11201400" cy="10972"/>
+          </a:xfrm>
+          <a:prstGeom prst="rect">
+            <a:avLst/>
+          </a:prstGeom>
+          <a:solidFill>
+            <a:srgbClr val="CBD5E1"/>
+          </a:solidFill>
+          <a:ln>
+            <a:noFill/>
+          </a:ln>
+        </p:spPr>
+        <p:style>
+          <a:lnRef idx="1">
+            <a:schemeClr val="accent1"/>
+          </a:lnRef>
+          <a:fillRef idx="3">
+            <a:schemeClr val="accent1"/>
+          </a:fillRef>
+          <a:effectRef idx="2">
+            <a:schemeClr val="accent1"/>
+          </a:effectRef>
+          <a:fontRef idx="minor">
+            <a:schemeClr val="lt1"/>
+          </a:fontRef>
+        </p:style>
+        <p:txBody>
+          <a:bodyPr rtlCol="0" anchor="ctr"/>
+          <a:lstStyle/>
+          <a:p>
+            <a:pPr algn="ctr"/>
+          </a:p>
+        </p:txBody>
+      </p:sp>
+      <p:sp>
+        <p:nvSpPr>
+          <p:cNvPr id="9" name="TextBox 8"/>
+          <p:cNvSpPr txBox="1"/>
+          <p:nvPr/>
+        </p:nvSpPr>
+        <p:spPr>
+          <a:xfrm>
+            <a:off x="384048" y="6473952"/>
+            <a:ext cx="5212080" cy="164592"/>
+          </a:xfrm>
+          <a:prstGeom prst="rect">
+            <a:avLst/>
+          </a:prstGeom>
+          <a:noFill/>
+        </p:spPr>
+        <p:txBody>
+          <a:bodyPr wrap="square" lIns="27432" rIns="27432" tIns="9144" bIns="9144" anchor="ctr">
+            <a:spAutoFit/>
+          </a:bodyPr>
+          <a:lstStyle/>
+          <a:p>
+            <a:pPr algn="l">
+              <a:defRPr sz="750" b="0">
+                <a:solidFill>
+                  <a:srgbClr val="64748B"/>
+                </a:solidFill>
+                <a:latin typeface="Microsoft YaHei"/>
+              </a:defRPr>
+            </a:pPr>
+            <a:r>
+              <a:rPr sz="750" b="0">
+                <a:solidFill>
+                  <a:srgbClr val="64748B"/>
+                </a:solidFill>
+                <a:latin typeface="Microsoft YaHei"/>
+              </a:rPr>
+              <a:t>Appendix: reviewer and instructor Q&amp;A</a:t>
+            </a:r>
+          </a:p>
+        </p:txBody>
+      </p:sp>
+      <p:sp>
+        <p:nvSpPr>
+          <p:cNvPr id="10" name="TextBox 9"/>
+          <p:cNvSpPr txBox="1"/>
+          <p:nvPr/>
+        </p:nvSpPr>
+        <p:spPr>
+          <a:xfrm>
+            <a:off x="10149840" y="6473952"/>
+            <a:ext cx="1417320" cy="164592"/>
+          </a:xfrm>
+          <a:prstGeom prst="rect">
+            <a:avLst/>
+          </a:prstGeom>
+          <a:noFill/>
+        </p:spPr>
+        <p:txBody>
+          <a:bodyPr wrap="square" lIns="27432" rIns="27432" tIns="9144" bIns="9144" anchor="ctr">
+            <a:spAutoFit/>
+          </a:bodyPr>
+          <a:lstStyle/>
+          <a:p>
+            <a:pPr algn="r">
+              <a:defRPr sz="750" b="1">
+                <a:solidFill>
+                  <a:srgbClr val="64748B"/>
+                </a:solidFill>
+                <a:latin typeface="Microsoft YaHei"/>
+              </a:defRPr>
+            </a:pPr>
+            <a:r>
+              <a:rPr sz="750" b="1">
+                <a:solidFill>
+                  <a:srgbClr val="64748B"/>
+                </a:solidFill>
+                <a:latin typeface="Microsoft YaHei"/>
+              </a:rPr>
+              <a:t>B7</a:t>
+            </a:r>
+          </a:p>
+        </p:txBody>
+      </p:sp>
+      <p:sp>
+        <p:nvSpPr>
+          <p:cNvPr id="11" name="Rounded Rectangle 10"/>
+          <p:cNvSpPr/>
+          <p:nvPr/>
+        </p:nvSpPr>
+        <p:spPr>
+          <a:xfrm>
+            <a:off x="658368" y="1115568"/>
+            <a:ext cx="10287000" cy="749808"/>
+          </a:xfrm>
+          <a:prstGeom prst="roundRect">
+            <a:avLst/>
+          </a:prstGeom>
+          <a:solidFill>
+            <a:srgbClr val="F1F5F9"/>
+          </a:solidFill>
+          <a:ln w="9525">
+            <a:solidFill>
+              <a:srgbClr val="CBD5E1"/>
+            </a:solidFill>
+          </a:ln>
+        </p:spPr>
+        <p:style>
+          <a:lnRef idx="1">
+            <a:schemeClr val="accent1"/>
+          </a:lnRef>
+          <a:fillRef idx="3">
+            <a:schemeClr val="accent1"/>
+          </a:fillRef>
+          <a:effectRef idx="2">
+            <a:schemeClr val="accent1"/>
+          </a:effectRef>
+          <a:fontRef idx="minor">
+            <a:schemeClr val="lt1"/>
+          </a:fontRef>
+        </p:style>
+        <p:txBody>
+          <a:bodyPr rtlCol="0" anchor="ctr"/>
+          <a:lstStyle/>
+          <a:p>
+            <a:pPr algn="ctr"/>
+          </a:p>
+        </p:txBody>
+      </p:sp>
+      <p:sp>
+        <p:nvSpPr>
+          <p:cNvPr id="12" name="TextBox 11"/>
+          <p:cNvSpPr txBox="1"/>
+          <p:nvPr/>
+        </p:nvSpPr>
+        <p:spPr>
+          <a:xfrm>
+            <a:off x="868680" y="1298448"/>
+            <a:ext cx="1463040" cy="182880"/>
+          </a:xfrm>
+          <a:prstGeom prst="rect">
+            <a:avLst/>
+          </a:prstGeom>
+          <a:noFill/>
+        </p:spPr>
+        <p:txBody>
+          <a:bodyPr wrap="square" lIns="27432" rIns="27432" tIns="9144" bIns="9144" anchor="ctr">
+            <a:spAutoFit/>
+          </a:bodyPr>
+          <a:lstStyle/>
+          <a:p>
+            <a:pPr algn="l">
+              <a:defRPr sz="1000" b="1">
+                <a:solidFill>
+                  <a:srgbClr val="EA580C"/>
+                </a:solidFill>
+                <a:latin typeface="Microsoft YaHei"/>
+              </a:defRPr>
+            </a:pPr>
+            <a:r>
+              <a:rPr sz="1000" b="1">
+                <a:solidFill>
+                  <a:srgbClr val="EA580C"/>
+                </a:solidFill>
+                <a:latin typeface="Microsoft YaHei"/>
+              </a:rPr>
+              <a:t>Short answer</a:t>
+            </a:r>
+          </a:p>
+        </p:txBody>
+      </p:sp>
+      <p:sp>
+        <p:nvSpPr>
+          <p:cNvPr id="13" name="TextBox 12"/>
+          <p:cNvSpPr txBox="1"/>
+          <p:nvPr/>
+        </p:nvSpPr>
+        <p:spPr>
+          <a:xfrm>
+            <a:off x="2240280" y="1216152"/>
+            <a:ext cx="8366760" cy="329184"/>
+          </a:xfrm>
+          <a:prstGeom prst="rect">
+            <a:avLst/>
+          </a:prstGeom>
+          <a:noFill/>
+        </p:spPr>
+        <p:txBody>
+          <a:bodyPr wrap="square" lIns="27432" rIns="27432" tIns="9144" bIns="9144" anchor="ctr">
+            <a:spAutoFit/>
+          </a:bodyPr>
+          <a:lstStyle/>
+          <a:p>
+            <a:pPr algn="l">
+              <a:defRPr sz="1300" b="1">
+                <a:solidFill>
+                  <a:srgbClr val="0F172A"/>
+                </a:solidFill>
+                <a:latin typeface="Microsoft YaHei"/>
+              </a:defRPr>
+            </a:pPr>
+            <a:r>
+              <a:rPr sz="1300" b="1">
+                <a:solidFill>
+                  <a:srgbClr val="0F172A"/>
+                </a:solidFill>
+                <a:latin typeface="Microsoft YaHei"/>
+              </a:rPr>
+              <a:t>有机制级外部验证；但没有 household-level external MAE，不能夸大。</a:t>
+            </a:r>
+          </a:p>
+        </p:txBody>
+      </p:sp>
+      <p:sp>
+        <p:nvSpPr>
+          <p:cNvPr id="14" name="Rectangle 13"/>
+          <p:cNvSpPr/>
+          <p:nvPr/>
+        </p:nvSpPr>
+        <p:spPr>
+          <a:xfrm>
+            <a:off x="713232" y="2176272"/>
+            <a:ext cx="4023360" cy="420624"/>
+          </a:xfrm>
+          <a:prstGeom prst="rect">
+            <a:avLst/>
+          </a:prstGeom>
+          <a:solidFill>
+            <a:srgbClr val="00796B"/>
+          </a:solidFill>
+          <a:ln>
+            <a:noFill/>
+          </a:ln>
+        </p:spPr>
+        <p:style>
+          <a:lnRef idx="1">
+            <a:schemeClr val="accent1"/>
+          </a:lnRef>
+          <a:fillRef idx="3">
+            <a:schemeClr val="accent1"/>
+          </a:fillRef>
+          <a:effectRef idx="2">
+            <a:schemeClr val="accent1"/>
+          </a:effectRef>
+          <a:fontRef idx="minor">
+            <a:schemeClr val="lt1"/>
+          </a:fontRef>
+        </p:style>
+        <p:txBody>
+          <a:bodyPr rtlCol="0" anchor="ctr"/>
+          <a:lstStyle/>
+          <a:p>
+            <a:pPr algn="ctr"/>
+          </a:p>
+        </p:txBody>
+      </p:sp>
+      <p:sp>
+        <p:nvSpPr>
+          <p:cNvPr id="15" name="TextBox 14"/>
+          <p:cNvSpPr txBox="1"/>
+          <p:nvPr/>
+        </p:nvSpPr>
+        <p:spPr>
+          <a:xfrm>
+            <a:off x="749808" y="2249424"/>
+            <a:ext cx="3950208" cy="292608"/>
+          </a:xfrm>
+          <a:prstGeom prst="rect">
+            <a:avLst/>
+          </a:prstGeom>
+          <a:noFill/>
+        </p:spPr>
+        <p:txBody>
+          <a:bodyPr wrap="square" lIns="27432" rIns="27432" tIns="9144" bIns="9144" anchor="ctr">
+            <a:spAutoFit/>
+          </a:bodyPr>
+          <a:lstStyle/>
+          <a:p>
+            <a:pPr algn="ctr">
+              <a:defRPr sz="1200" b="1">
+                <a:solidFill>
+                  <a:srgbClr val="FFFFFF"/>
+                </a:solidFill>
+                <a:latin typeface="Microsoft YaHei"/>
+              </a:defRPr>
+            </a:pPr>
+            <a:r>
+              <a:rPr sz="1200" b="1">
+                <a:solidFill>
+                  <a:srgbClr val="FFFFFF"/>
+                </a:solidFill>
+                <a:latin typeface="Microsoft YaHei"/>
+              </a:rPr>
+              <a:t>Evidence</a:t>
+            </a:r>
+          </a:p>
+        </p:txBody>
+      </p:sp>
+      <p:sp>
+        <p:nvSpPr>
+          <p:cNvPr id="16" name="Rectangle 15"/>
+          <p:cNvSpPr/>
+          <p:nvPr/>
+        </p:nvSpPr>
+        <p:spPr>
+          <a:xfrm>
+            <a:off x="4736592" y="2176272"/>
+            <a:ext cx="6035040" cy="420624"/>
+          </a:xfrm>
+          <a:prstGeom prst="rect">
+            <a:avLst/>
+          </a:prstGeom>
+          <a:solidFill>
+            <a:srgbClr val="00796B"/>
+          </a:solidFill>
+          <a:ln>
+            <a:noFill/>
+          </a:ln>
+        </p:spPr>
+        <p:style>
+          <a:lnRef idx="1">
+            <a:schemeClr val="accent1"/>
+          </a:lnRef>
+          <a:fillRef idx="3">
+            <a:schemeClr val="accent1"/>
+          </a:fillRef>
+          <a:effectRef idx="2">
+            <a:schemeClr val="accent1"/>
+          </a:effectRef>
+          <a:fontRef idx="minor">
+            <a:schemeClr val="lt1"/>
+          </a:fontRef>
+        </p:style>
+        <p:txBody>
+          <a:bodyPr rtlCol="0" anchor="ctr"/>
+          <a:lstStyle/>
+          <a:p>
+            <a:pPr algn="ctr"/>
+          </a:p>
+        </p:txBody>
+      </p:sp>
+      <p:sp>
+        <p:nvSpPr>
+          <p:cNvPr id="17" name="TextBox 16"/>
+          <p:cNvSpPr txBox="1"/>
+          <p:nvPr/>
+        </p:nvSpPr>
+        <p:spPr>
+          <a:xfrm>
+            <a:off x="4773168" y="2249424"/>
+            <a:ext cx="5961888" cy="292608"/>
+          </a:xfrm>
+          <a:prstGeom prst="rect">
+            <a:avLst/>
+          </a:prstGeom>
+          <a:noFill/>
+        </p:spPr>
+        <p:txBody>
+          <a:bodyPr wrap="square" lIns="27432" rIns="27432" tIns="9144" bIns="9144" anchor="ctr">
+            <a:spAutoFit/>
+          </a:bodyPr>
+          <a:lstStyle/>
+          <a:p>
+            <a:pPr algn="ctr">
+              <a:defRPr sz="1200" b="1">
+                <a:solidFill>
+                  <a:srgbClr val="FFFFFF"/>
+                </a:solidFill>
+                <a:latin typeface="Microsoft YaHei"/>
+              </a:defRPr>
+            </a:pPr>
+            <a:r>
+              <a:rPr sz="1200" b="1">
+                <a:solidFill>
+                  <a:srgbClr val="FFFFFF"/>
+                </a:solidFill>
+                <a:latin typeface="Microsoft YaHei"/>
+              </a:rPr>
+              <a:t>Value / implication</a:t>
+            </a:r>
+          </a:p>
+        </p:txBody>
+      </p:sp>
+      <p:sp>
+        <p:nvSpPr>
+          <p:cNvPr id="18" name="Rectangle 17"/>
+          <p:cNvSpPr/>
+          <p:nvPr/>
+        </p:nvSpPr>
+        <p:spPr>
+          <a:xfrm>
+            <a:off x="713232" y="2596896"/>
+            <a:ext cx="4023360" cy="420624"/>
+          </a:xfrm>
+          <a:prstGeom prst="rect">
+            <a:avLst/>
+          </a:prstGeom>
+          <a:solidFill>
+            <a:srgbClr val="F8FAFC"/>
+          </a:solidFill>
+          <a:ln w="9525">
+            <a:solidFill>
+              <a:srgbClr val="CBD5E1"/>
+            </a:solidFill>
+          </a:ln>
+        </p:spPr>
+        <p:style>
+          <a:lnRef idx="1">
+            <a:schemeClr val="accent1"/>
+          </a:lnRef>
+          <a:fillRef idx="3">
+            <a:schemeClr val="accent1"/>
+          </a:fillRef>
+          <a:effectRef idx="2">
+            <a:schemeClr val="accent1"/>
+          </a:effectRef>
+          <a:fontRef idx="minor">
+            <a:schemeClr val="lt1"/>
+          </a:fontRef>
+        </p:style>
+        <p:txBody>
+          <a:bodyPr rtlCol="0" anchor="ctr"/>
+          <a:lstStyle/>
+          <a:p>
+            <a:pPr algn="ctr"/>
+          </a:p>
+        </p:txBody>
+      </p:sp>
+      <p:sp>
+        <p:nvSpPr>
+          <p:cNvPr id="19" name="TextBox 18"/>
+          <p:cNvSpPr txBox="1"/>
+          <p:nvPr/>
+        </p:nvSpPr>
+        <p:spPr>
+          <a:xfrm>
+            <a:off x="768096" y="2660903"/>
+            <a:ext cx="3913632" cy="292608"/>
+          </a:xfrm>
+          <a:prstGeom prst="rect">
+            <a:avLst/>
+          </a:prstGeom>
+          <a:noFill/>
+        </p:spPr>
+        <p:txBody>
+          <a:bodyPr wrap="square" lIns="27432" rIns="27432" tIns="9144" bIns="9144" anchor="t">
+            <a:spAutoFit/>
+          </a:bodyPr>
+          <a:lstStyle/>
+          <a:p>
+            <a:pPr algn="l">
+              <a:defRPr sz="1200" b="1">
+                <a:solidFill>
+                  <a:srgbClr val="0F172A"/>
+                </a:solidFill>
+                <a:latin typeface="Microsoft YaHei"/>
+              </a:defRPr>
+            </a:pPr>
+            <a:r>
+              <a:rPr sz="1200" b="1">
+                <a:solidFill>
+                  <a:srgbClr val="0F172A"/>
+                </a:solidFill>
+                <a:latin typeface="Microsoft YaHei"/>
+              </a:rPr>
+              <a:t>ACS work from home</a:t>
+            </a:r>
+          </a:p>
+        </p:txBody>
+      </p:sp>
+      <p:sp>
+        <p:nvSpPr>
+          <p:cNvPr id="20" name="Rectangle 19"/>
+          <p:cNvSpPr/>
+          <p:nvPr/>
+        </p:nvSpPr>
+        <p:spPr>
+          <a:xfrm>
+            <a:off x="4736592" y="2596896"/>
+            <a:ext cx="6035040" cy="420624"/>
+          </a:xfrm>
+          <a:prstGeom prst="rect">
+            <a:avLst/>
+          </a:prstGeom>
+          <a:solidFill>
+            <a:srgbClr val="F8FAFC"/>
+          </a:solidFill>
+          <a:ln w="9525">
+            <a:solidFill>
+              <a:srgbClr val="CBD5E1"/>
+            </a:solidFill>
+          </a:ln>
+        </p:spPr>
+        <p:style>
+          <a:lnRef idx="1">
+            <a:schemeClr val="accent1"/>
+          </a:lnRef>
+          <a:fillRef idx="3">
+            <a:schemeClr val="accent1"/>
+          </a:fillRef>
+          <a:effectRef idx="2">
+            <a:schemeClr val="accent1"/>
+          </a:effectRef>
+          <a:fontRef idx="minor">
+            <a:schemeClr val="lt1"/>
+          </a:fontRef>
+        </p:style>
+        <p:txBody>
+          <a:bodyPr rtlCol="0" anchor="ctr"/>
+          <a:lstStyle/>
+          <a:p>
+            <a:pPr algn="ctr"/>
+          </a:p>
+        </p:txBody>
+      </p:sp>
+      <p:sp>
+        <p:nvSpPr>
+          <p:cNvPr id="21" name="TextBox 20"/>
+          <p:cNvSpPr txBox="1"/>
+          <p:nvPr/>
+        </p:nvSpPr>
+        <p:spPr>
+          <a:xfrm>
+            <a:off x="4791456" y="2660903"/>
+            <a:ext cx="5925312" cy="292608"/>
+          </a:xfrm>
+          <a:prstGeom prst="rect">
+            <a:avLst/>
+          </a:prstGeom>
+          <a:noFill/>
+        </p:spPr>
+        <p:txBody>
+          <a:bodyPr wrap="square" lIns="27432" rIns="27432" tIns="9144" bIns="9144" anchor="t">
+            <a:spAutoFit/>
+          </a:bodyPr>
+          <a:lstStyle/>
+          <a:p>
+            <a:pPr algn="l">
+              <a:defRPr sz="1200" b="0">
+                <a:solidFill>
+                  <a:srgbClr val="0F172A"/>
+                </a:solidFill>
+                <a:latin typeface="Microsoft YaHei"/>
+              </a:defRPr>
+            </a:pPr>
+            <a:r>
+              <a:rPr sz="1200" b="0">
+                <a:solidFill>
+                  <a:srgbClr val="0F172A"/>
+                </a:solidFill>
+                <a:latin typeface="Microsoft YaHei"/>
+              </a:rPr>
+              <a:t>2019 5.7% -&gt; 2022 15.2%; supports remote-work prior</a:t>
+            </a:r>
+          </a:p>
+        </p:txBody>
+      </p:sp>
+      <p:sp>
+        <p:nvSpPr>
+          <p:cNvPr id="22" name="Rectangle 21"/>
+          <p:cNvSpPr/>
+          <p:nvPr/>
+        </p:nvSpPr>
+        <p:spPr>
+          <a:xfrm>
+            <a:off x="713232" y="3017520"/>
+            <a:ext cx="4023360" cy="420624"/>
+          </a:xfrm>
+          <a:prstGeom prst="rect">
+            <a:avLst/>
+          </a:prstGeom>
+          <a:solidFill>
+            <a:srgbClr val="F1F5F9"/>
+          </a:solidFill>
+          <a:ln w="9525">
+            <a:solidFill>
+              <a:srgbClr val="CBD5E1"/>
+            </a:solidFill>
+          </a:ln>
+        </p:spPr>
+        <p:style>
+          <a:lnRef idx="1">
+            <a:schemeClr val="accent1"/>
+          </a:lnRef>
+          <a:fillRef idx="3">
+            <a:schemeClr val="accent1"/>
+          </a:fillRef>
+          <a:effectRef idx="2">
+            <a:schemeClr val="accent1"/>
+          </a:effectRef>
+          <a:fontRef idx="minor">
+            <a:schemeClr val="lt1"/>
+          </a:fontRef>
+        </p:style>
+        <p:txBody>
+          <a:bodyPr rtlCol="0" anchor="ctr"/>
+          <a:lstStyle/>
+          <a:p>
+            <a:pPr algn="ctr"/>
+          </a:p>
+        </p:txBody>
+      </p:sp>
+      <p:sp>
+        <p:nvSpPr>
+          <p:cNvPr id="23" name="TextBox 22"/>
+          <p:cNvSpPr txBox="1"/>
+          <p:nvPr/>
+        </p:nvSpPr>
+        <p:spPr>
+          <a:xfrm>
+            <a:off x="768096" y="3081527"/>
+            <a:ext cx="3913632" cy="292608"/>
+          </a:xfrm>
+          <a:prstGeom prst="rect">
+            <a:avLst/>
+          </a:prstGeom>
+          <a:noFill/>
+        </p:spPr>
+        <p:txBody>
+          <a:bodyPr wrap="square" lIns="27432" rIns="27432" tIns="9144" bIns="9144" anchor="t">
+            <a:spAutoFit/>
+          </a:bodyPr>
+          <a:lstStyle/>
+          <a:p>
+            <a:pPr algn="l">
+              <a:defRPr sz="1200" b="1">
+                <a:solidFill>
+                  <a:srgbClr val="0F172A"/>
+                </a:solidFill>
+                <a:latin typeface="Microsoft YaHei"/>
+              </a:defRPr>
+            </a:pPr>
+            <a:r>
+              <a:rPr sz="1200" b="1">
+                <a:solidFill>
+                  <a:srgbClr val="0F172A"/>
+                </a:solidFill>
+                <a:latin typeface="Microsoft YaHei"/>
+              </a:rPr>
+              <a:t>ACS public transit</a:t>
+            </a:r>
+          </a:p>
+        </p:txBody>
+      </p:sp>
+      <p:sp>
+        <p:nvSpPr>
+          <p:cNvPr id="24" name="Rectangle 23"/>
+          <p:cNvSpPr/>
+          <p:nvPr/>
+        </p:nvSpPr>
+        <p:spPr>
+          <a:xfrm>
+            <a:off x="4736592" y="3017520"/>
+            <a:ext cx="6035040" cy="420624"/>
+          </a:xfrm>
+          <a:prstGeom prst="rect">
+            <a:avLst/>
+          </a:prstGeom>
+          <a:solidFill>
+            <a:srgbClr val="F1F5F9"/>
+          </a:solidFill>
+          <a:ln w="9525">
+            <a:solidFill>
+              <a:srgbClr val="CBD5E1"/>
+            </a:solidFill>
+          </a:ln>
+        </p:spPr>
+        <p:style>
+          <a:lnRef idx="1">
+            <a:schemeClr val="accent1"/>
+          </a:lnRef>
+          <a:fillRef idx="3">
+            <a:schemeClr val="accent1"/>
+          </a:fillRef>
+          <a:effectRef idx="2">
+            <a:schemeClr val="accent1"/>
+          </a:effectRef>
+          <a:fontRef idx="minor">
+            <a:schemeClr val="lt1"/>
+          </a:fontRef>
+        </p:style>
+        <p:txBody>
+          <a:bodyPr rtlCol="0" anchor="ctr"/>
+          <a:lstStyle/>
+          <a:p>
+            <a:pPr algn="ctr"/>
+          </a:p>
+        </p:txBody>
+      </p:sp>
+      <p:sp>
+        <p:nvSpPr>
+          <p:cNvPr id="25" name="TextBox 24"/>
+          <p:cNvSpPr txBox="1"/>
+          <p:nvPr/>
+        </p:nvSpPr>
+        <p:spPr>
+          <a:xfrm>
+            <a:off x="4791456" y="3081527"/>
+            <a:ext cx="5925312" cy="292608"/>
+          </a:xfrm>
+          <a:prstGeom prst="rect">
+            <a:avLst/>
+          </a:prstGeom>
+          <a:noFill/>
+        </p:spPr>
+        <p:txBody>
+          <a:bodyPr wrap="square" lIns="27432" rIns="27432" tIns="9144" bIns="9144" anchor="t">
+            <a:spAutoFit/>
+          </a:bodyPr>
+          <a:lstStyle/>
+          <a:p>
+            <a:pPr algn="l">
+              <a:defRPr sz="1200" b="0">
+                <a:solidFill>
+                  <a:srgbClr val="0F172A"/>
+                </a:solidFill>
+                <a:latin typeface="Microsoft YaHei"/>
+              </a:defRPr>
+            </a:pPr>
+            <a:r>
+              <a:rPr sz="1200" b="0">
+                <a:solidFill>
+                  <a:srgbClr val="0F172A"/>
+                </a:solidFill>
+                <a:latin typeface="Microsoft YaHei"/>
+              </a:rPr>
+              <a:t>2019 5.0% -&gt; 2022 3.1%; supports transit-avoidance prior</a:t>
+            </a:r>
+          </a:p>
+        </p:txBody>
+      </p:sp>
+      <p:sp>
+        <p:nvSpPr>
+          <p:cNvPr id="26" name="Rectangle 25"/>
+          <p:cNvSpPr/>
+          <p:nvPr/>
+        </p:nvSpPr>
+        <p:spPr>
+          <a:xfrm>
+            <a:off x="713232" y="3438144"/>
+            <a:ext cx="4023360" cy="420624"/>
+          </a:xfrm>
+          <a:prstGeom prst="rect">
+            <a:avLst/>
+          </a:prstGeom>
+          <a:solidFill>
+            <a:srgbClr val="F8FAFC"/>
+          </a:solidFill>
+          <a:ln w="9525">
+            <a:solidFill>
+              <a:srgbClr val="CBD5E1"/>
+            </a:solidFill>
+          </a:ln>
+        </p:spPr>
+        <p:style>
+          <a:lnRef idx="1">
+            <a:schemeClr val="accent1"/>
+          </a:lnRef>
+          <a:fillRef idx="3">
+            <a:schemeClr val="accent1"/>
+          </a:fillRef>
+          <a:effectRef idx="2">
+            <a:schemeClr val="accent1"/>
+          </a:effectRef>
+          <a:fontRef idx="minor">
+            <a:schemeClr val="lt1"/>
+          </a:fontRef>
+        </p:style>
+        <p:txBody>
+          <a:bodyPr rtlCol="0" anchor="ctr"/>
+          <a:lstStyle/>
+          <a:p>
+            <a:pPr algn="ctr"/>
+          </a:p>
+        </p:txBody>
+      </p:sp>
+      <p:sp>
+        <p:nvSpPr>
+          <p:cNvPr id="27" name="TextBox 26"/>
+          <p:cNvSpPr txBox="1"/>
+          <p:nvPr/>
+        </p:nvSpPr>
+        <p:spPr>
+          <a:xfrm>
+            <a:off x="768096" y="3502151"/>
+            <a:ext cx="3913632" cy="292608"/>
+          </a:xfrm>
+          <a:prstGeom prst="rect">
+            <a:avLst/>
+          </a:prstGeom>
+          <a:noFill/>
+        </p:spPr>
+        <p:txBody>
+          <a:bodyPr wrap="square" lIns="27432" rIns="27432" tIns="9144" bIns="9144" anchor="t">
+            <a:spAutoFit/>
+          </a:bodyPr>
+          <a:lstStyle/>
+          <a:p>
+            <a:pPr algn="l">
+              <a:defRPr sz="1200" b="1">
+                <a:solidFill>
+                  <a:srgbClr val="0F172A"/>
+                </a:solidFill>
+                <a:latin typeface="Microsoft YaHei"/>
+              </a:defRPr>
+            </a:pPr>
+            <a:r>
+              <a:rPr sz="1200" b="1">
+                <a:solidFill>
+                  <a:srgbClr val="0F172A"/>
+                </a:solidFill>
+                <a:latin typeface="Microsoft YaHei"/>
+              </a:rPr>
+              <a:t>BTS daily mobility</a:t>
+            </a:r>
+          </a:p>
+        </p:txBody>
+      </p:sp>
+      <p:sp>
+        <p:nvSpPr>
+          <p:cNvPr id="28" name="Rectangle 27"/>
+          <p:cNvSpPr/>
+          <p:nvPr/>
+        </p:nvSpPr>
+        <p:spPr>
+          <a:xfrm>
+            <a:off x="4736592" y="3438144"/>
+            <a:ext cx="6035040" cy="420624"/>
+          </a:xfrm>
+          <a:prstGeom prst="rect">
+            <a:avLst/>
+          </a:prstGeom>
+          <a:solidFill>
+            <a:srgbClr val="F8FAFC"/>
+          </a:solidFill>
+          <a:ln w="9525">
+            <a:solidFill>
+              <a:srgbClr val="CBD5E1"/>
+            </a:solidFill>
+          </a:ln>
+        </p:spPr>
+        <p:style>
+          <a:lnRef idx="1">
+            <a:schemeClr val="accent1"/>
+          </a:lnRef>
+          <a:fillRef idx="3">
+            <a:schemeClr val="accent1"/>
+          </a:fillRef>
+          <a:effectRef idx="2">
+            <a:schemeClr val="accent1"/>
+          </a:effectRef>
+          <a:fontRef idx="minor">
+            <a:schemeClr val="lt1"/>
+          </a:fontRef>
+        </p:style>
+        <p:txBody>
+          <a:bodyPr rtlCol="0" anchor="ctr"/>
+          <a:lstStyle/>
+          <a:p>
+            <a:pPr algn="ctr"/>
+          </a:p>
+        </p:txBody>
+      </p:sp>
+      <p:sp>
+        <p:nvSpPr>
+          <p:cNvPr id="29" name="TextBox 28"/>
+          <p:cNvSpPr txBox="1"/>
+          <p:nvPr/>
+        </p:nvSpPr>
+        <p:spPr>
+          <a:xfrm>
+            <a:off x="4791456" y="3502151"/>
+            <a:ext cx="5925312" cy="292608"/>
+          </a:xfrm>
+          <a:prstGeom prst="rect">
+            <a:avLst/>
+          </a:prstGeom>
+          <a:noFill/>
+        </p:spPr>
+        <p:txBody>
+          <a:bodyPr wrap="square" lIns="27432" rIns="27432" tIns="9144" bIns="9144" anchor="t">
+            <a:spAutoFit/>
+          </a:bodyPr>
+          <a:lstStyle/>
+          <a:p>
+            <a:pPr algn="l">
+              <a:defRPr sz="1200" b="0">
+                <a:solidFill>
+                  <a:srgbClr val="0F172A"/>
+                </a:solidFill>
+                <a:latin typeface="Microsoft YaHei"/>
+              </a:defRPr>
+            </a:pPr>
+            <a:r>
+              <a:rPr sz="1200" b="0">
+                <a:solidFill>
+                  <a:srgbClr val="0F172A"/>
+                </a:solidFill>
+                <a:latin typeface="Microsoft YaHei"/>
+              </a:rPr>
+              <a:t>Device trips/person is not a direct CNTTDHH label</a:t>
+            </a:r>
+          </a:p>
+        </p:txBody>
+      </p:sp>
+      <p:sp>
+        <p:nvSpPr>
+          <p:cNvPr id="30" name="Rectangle 29"/>
+          <p:cNvSpPr/>
+          <p:nvPr/>
+        </p:nvSpPr>
+        <p:spPr>
+          <a:xfrm>
+            <a:off x="713232" y="3858768"/>
+            <a:ext cx="4023360" cy="420624"/>
+          </a:xfrm>
+          <a:prstGeom prst="rect">
+            <a:avLst/>
+          </a:prstGeom>
+          <a:solidFill>
+            <a:srgbClr val="F1F5F9"/>
+          </a:solidFill>
+          <a:ln w="9525">
+            <a:solidFill>
+              <a:srgbClr val="CBD5E1"/>
+            </a:solidFill>
+          </a:ln>
+        </p:spPr>
+        <p:style>
+          <a:lnRef idx="1">
+            <a:schemeClr val="accent1"/>
+          </a:lnRef>
+          <a:fillRef idx="3">
+            <a:schemeClr val="accent1"/>
+          </a:fillRef>
+          <a:effectRef idx="2">
+            <a:schemeClr val="accent1"/>
+          </a:effectRef>
+          <a:fontRef idx="minor">
+            <a:schemeClr val="lt1"/>
+          </a:fontRef>
+        </p:style>
+        <p:txBody>
+          <a:bodyPr rtlCol="0" anchor="ctr"/>
+          <a:lstStyle/>
+          <a:p>
+            <a:pPr algn="ctr"/>
+          </a:p>
+        </p:txBody>
+      </p:sp>
+      <p:sp>
+        <p:nvSpPr>
+          <p:cNvPr id="31" name="TextBox 30"/>
+          <p:cNvSpPr txBox="1"/>
+          <p:nvPr/>
+        </p:nvSpPr>
+        <p:spPr>
+          <a:xfrm>
+            <a:off x="768096" y="3922776"/>
+            <a:ext cx="3913632" cy="292608"/>
+          </a:xfrm>
+          <a:prstGeom prst="rect">
+            <a:avLst/>
+          </a:prstGeom>
+          <a:noFill/>
+        </p:spPr>
+        <p:txBody>
+          <a:bodyPr wrap="square" lIns="27432" rIns="27432" tIns="9144" bIns="9144" anchor="t">
+            <a:spAutoFit/>
+          </a:bodyPr>
+          <a:lstStyle/>
+          <a:p>
+            <a:pPr algn="l">
+              <a:defRPr sz="1200" b="1">
+                <a:solidFill>
+                  <a:srgbClr val="0F172A"/>
+                </a:solidFill>
+                <a:latin typeface="Microsoft YaHei"/>
+              </a:defRPr>
+            </a:pPr>
+            <a:r>
+              <a:rPr sz="1200" b="1">
+                <a:solidFill>
+                  <a:srgbClr val="0F172A"/>
+                </a:solidFill>
+                <a:latin typeface="Microsoft YaHei"/>
+              </a:rPr>
+              <a:t>Safe claim</a:t>
+            </a:r>
+          </a:p>
+        </p:txBody>
+      </p:sp>
+      <p:sp>
+        <p:nvSpPr>
+          <p:cNvPr id="32" name="Rectangle 31"/>
+          <p:cNvSpPr/>
+          <p:nvPr/>
+        </p:nvSpPr>
+        <p:spPr>
+          <a:xfrm>
+            <a:off x="4736592" y="3858768"/>
+            <a:ext cx="6035040" cy="420624"/>
+          </a:xfrm>
+          <a:prstGeom prst="rect">
+            <a:avLst/>
+          </a:prstGeom>
+          <a:solidFill>
+            <a:srgbClr val="F1F5F9"/>
+          </a:solidFill>
+          <a:ln w="9525">
+            <a:solidFill>
+              <a:srgbClr val="CBD5E1"/>
+            </a:solidFill>
+          </a:ln>
+        </p:spPr>
+        <p:style>
+          <a:lnRef idx="1">
+            <a:schemeClr val="accent1"/>
+          </a:lnRef>
+          <a:fillRef idx="3">
+            <a:schemeClr val="accent1"/>
+          </a:fillRef>
+          <a:effectRef idx="2">
+            <a:schemeClr val="accent1"/>
+          </a:effectRef>
+          <a:fontRef idx="minor">
+            <a:schemeClr val="lt1"/>
+          </a:fontRef>
+        </p:style>
+        <p:txBody>
+          <a:bodyPr rtlCol="0" anchor="ctr"/>
+          <a:lstStyle/>
+          <a:p>
+            <a:pPr algn="ctr"/>
+          </a:p>
+        </p:txBody>
+      </p:sp>
+      <p:sp>
+        <p:nvSpPr>
+          <p:cNvPr id="33" name="TextBox 32"/>
+          <p:cNvSpPr txBox="1"/>
+          <p:nvPr/>
+        </p:nvSpPr>
+        <p:spPr>
+          <a:xfrm>
+            <a:off x="4791456" y="3922776"/>
+            <a:ext cx="5925312" cy="292608"/>
+          </a:xfrm>
+          <a:prstGeom prst="rect">
+            <a:avLst/>
+          </a:prstGeom>
+          <a:noFill/>
+        </p:spPr>
+        <p:txBody>
+          <a:bodyPr wrap="square" lIns="27432" rIns="27432" tIns="9144" bIns="9144" anchor="t">
+            <a:spAutoFit/>
+          </a:bodyPr>
+          <a:lstStyle/>
+          <a:p>
+            <a:pPr algn="l">
+              <a:defRPr sz="1200" b="0">
+                <a:solidFill>
+                  <a:srgbClr val="0F172A"/>
+                </a:solidFill>
+                <a:latin typeface="Microsoft YaHei"/>
+              </a:defRPr>
+            </a:pPr>
+            <a:r>
+              <a:rPr sz="1200" b="0">
+                <a:solidFill>
+                  <a:srgbClr val="0F172A"/>
+                </a:solidFill>
+                <a:latin typeface="Microsoft YaHei"/>
+              </a:rPr>
+              <a:t>External mechanism support + compatibility guardrail</a:t>
+            </a:r>
+          </a:p>
+        </p:txBody>
+      </p:sp>
+      <p:sp>
+        <p:nvSpPr>
+          <p:cNvPr id="34" name="Rounded Rectangle 33"/>
+          <p:cNvSpPr/>
+          <p:nvPr/>
+        </p:nvSpPr>
+        <p:spPr>
+          <a:xfrm>
+            <a:off x="749808" y="5074920"/>
+            <a:ext cx="10012680" cy="1005840"/>
+          </a:xfrm>
+          <a:prstGeom prst="roundRect">
+            <a:avLst/>
+          </a:prstGeom>
+          <a:solidFill>
+            <a:srgbClr val="F1F5F9"/>
+          </a:solidFill>
+          <a:ln w="9525">
+            <a:solidFill>
+              <a:srgbClr val="CBD5E1"/>
+            </a:solidFill>
+          </a:ln>
+        </p:spPr>
+        <p:style>
+          <a:lnRef idx="1">
+            <a:schemeClr val="accent1"/>
+          </a:lnRef>
+          <a:fillRef idx="3">
+            <a:schemeClr val="accent1"/>
+          </a:fillRef>
+          <a:effectRef idx="2">
+            <a:schemeClr val="accent1"/>
+          </a:effectRef>
+          <a:fontRef idx="minor">
+            <a:schemeClr val="lt1"/>
+          </a:fontRef>
+        </p:style>
+        <p:txBody>
+          <a:bodyPr rtlCol="0" anchor="ctr"/>
+          <a:lstStyle/>
+          <a:p>
+            <a:pPr algn="ctr"/>
+          </a:p>
+        </p:txBody>
+      </p:sp>
+      <p:sp>
+        <p:nvSpPr>
+          <p:cNvPr id="35" name="Rectangle 34"/>
+          <p:cNvSpPr/>
+          <p:nvPr/>
+        </p:nvSpPr>
+        <p:spPr>
+          <a:xfrm>
+            <a:off x="749808" y="5074920"/>
+            <a:ext cx="50292" cy="1005840"/>
+          </a:xfrm>
+          <a:prstGeom prst="rect">
+            <a:avLst/>
+          </a:prstGeom>
+          <a:solidFill>
+            <a:srgbClr val="2563EB"/>
+          </a:solidFill>
+          <a:ln>
+            <a:noFill/>
+          </a:ln>
+        </p:spPr>
+        <p:style>
+          <a:lnRef idx="1">
+            <a:schemeClr val="accent1"/>
+          </a:lnRef>
+          <a:fillRef idx="3">
+            <a:schemeClr val="accent1"/>
+          </a:fillRef>
+          <a:effectRef idx="2">
+            <a:schemeClr val="accent1"/>
+          </a:effectRef>
+          <a:fontRef idx="minor">
+            <a:schemeClr val="lt1"/>
+          </a:fontRef>
+        </p:style>
+        <p:txBody>
+          <a:bodyPr rtlCol="0" anchor="ctr"/>
+          <a:lstStyle/>
+          <a:p>
+            <a:pPr algn="ctr"/>
+          </a:p>
+        </p:txBody>
+      </p:sp>
+      <p:sp>
+        <p:nvSpPr>
+          <p:cNvPr id="36" name="TextBox 35"/>
+          <p:cNvSpPr txBox="1"/>
+          <p:nvPr/>
+        </p:nvSpPr>
+        <p:spPr>
+          <a:xfrm>
+            <a:off x="914400" y="5166359"/>
+            <a:ext cx="9720072" cy="362102"/>
+          </a:xfrm>
+          <a:prstGeom prst="rect">
+            <a:avLst/>
+          </a:prstGeom>
+          <a:noFill/>
+        </p:spPr>
+        <p:txBody>
+          <a:bodyPr wrap="square" lIns="27432" rIns="27432" tIns="9144" bIns="9144" anchor="t">
+            <a:spAutoFit/>
+          </a:bodyPr>
+          <a:lstStyle/>
+          <a:p>
+            <a:pPr algn="l">
+              <a:defRPr sz="1200" b="1">
+                <a:solidFill>
+                  <a:srgbClr val="0F172A"/>
+                </a:solidFill>
+                <a:latin typeface="Microsoft YaHei"/>
+              </a:defRPr>
+            </a:pPr>
+            <a:r>
+              <a:rPr sz="1200" b="1">
+                <a:solidFill>
+                  <a:srgbClr val="0F172A"/>
+                </a:solidFill>
+                <a:latin typeface="Microsoft YaHei"/>
+              </a:rPr>
+              <a:t>答法：我们用 ACS 证明疫情后通勤机制确实发生了远程办公和公共交通下降；同时用 BTS 做 guardrail，说明 device mobility trips 不能直接当作 NHTS household trip-count 的外部标签。论文版还需要兼容的 household travel survey microdata。</a:t>
+            </a:r>
+          </a:p>
+        </p:txBody>
+      </p:sp>
+      <p:sp>
+        <p:nvSpPr>
+          <p:cNvPr id="37" name="TextBox 36"/>
+          <p:cNvSpPr txBox="1"/>
+          <p:nvPr/>
+        </p:nvSpPr>
+        <p:spPr>
+          <a:xfrm>
+            <a:off x="914400" y="5592470"/>
+            <a:ext cx="9720072" cy="415137"/>
+          </a:xfrm>
+          <a:prstGeom prst="rect">
+            <a:avLst/>
+          </a:prstGeom>
+          <a:noFill/>
+        </p:spPr>
+        <p:txBody>
+          <a:bodyPr wrap="square" lIns="27432" rIns="27432" tIns="9144" bIns="9144" anchor="t">
+            <a:spAutoFit/>
+          </a:bodyPr>
+          <a:lstStyle/>
+          <a:p>
+            <a:pPr algn="l">
+              <a:defRPr sz="1200" b="0">
+                <a:solidFill>
+                  <a:srgbClr val="64748B"/>
+                </a:solidFill>
+                <a:latin typeface="Microsoft YaHei"/>
+              </a:defRPr>
+            </a:pPr>
           </a:p>
         </p:txBody>
       </p:sp>

</xml_diff>

<commit_message>
feat(research): add psrc external household validation
</commit_message>
<xml_diff>
--- a/outputs/final_project/NHTS_Travel_Behavior_Template_Presentation.pptx
+++ b/outputs/final_project/NHTS_Travel_Behavior_Template_Presentation.pptx
@@ -45024,7 +45024,7 @@
                 </a:solidFill>
                 <a:latin typeface="Microsoft YaHei"/>
               </a:rPr>
-              <a:t>有机制级外部验证；但没有 household-level external MAE，不能夸大。</a:t>
+              <a:t>有机制级验证和 PSRC household microdata；但不是 NHTS 2022 的直接复刻。</a:t>
             </a:r>
           </a:p>
         </p:txBody>
@@ -45629,7 +45629,7 @@
                 </a:solidFill>
                 <a:latin typeface="Microsoft YaHei"/>
               </a:rPr>
-              <a:t>BTS daily mobility</a:t>
+              <a:t>PSRC microdata</a:t>
             </a:r>
           </a:p>
         </p:txBody>
@@ -45716,7 +45716,7 @@
                 </a:solidFill>
                 <a:latin typeface="Microsoft YaHei"/>
               </a:rPr>
-              <a:t>Device trips/person is not a direct CNTTDHH label</a:t>
+              <a:t>2021-&gt;2023 wMAE 3.6908-&gt;3.6855; wBias -1.1480-&gt;-0.2646</a:t>
             </a:r>
           </a:p>
         </p:txBody>
@@ -45890,7 +45890,7 @@
                 </a:solidFill>
                 <a:latin typeface="Microsoft YaHei"/>
               </a:rPr>
-              <a:t>External mechanism support + compatibility guardrail</a:t>
+              <a:t>External mechanism + recovery-transfer support</a:t>
             </a:r>
           </a:p>
         </p:txBody>
@@ -46020,7 +46020,7 @@
                 </a:solidFill>
                 <a:latin typeface="Microsoft YaHei"/>
               </a:rPr>
-              <a:t>答法：我们用 ACS 证明疫情后通勤机制确实发生了远程办公和公共交通下降；同时用 BTS 做 guardrail，说明 device mobility trips 不能直接当作 NHTS household trip-count 的外部标签。论文版还需要兼容的 household travel survey microdata。</a:t>
+              <a:t>答法：我们用 ACS 证明疫情后通勤机制确实发生了远程办公和公共交通下降；用 PSRC 独立 household microdata 做 recovery-transfer 验证；同时用 BTS 做 guardrail，说明 device mobility trips 不能直接当作 NHTS household trip-count 的外部标签。</a:t>
             </a:r>
           </a:p>
         </p:txBody>

</xml_diff>